<commit_message>
Prepare l'insertion automatique des logos dans le diaporama
- build_pptx.py detecte les fichiers deposes dans rapport/logos/ (santerne,
  vinci, irup/asder) et les place : bandeau bas de la page de titre, coin
  haut droit des diapositives, bas de la diapositive de conclusion.
- Rapport d'aspect respecte, aucun emplacement vide si les fichiers sont
  absents (le rendu reste identique).
- Notice LISEZ-MOI dans rapport/logos/ avec les noms de fichiers attendus.
- Page de titre reequilibree (titre sur deux lignes, filet abaisse).

Les fichiers de logo ne sont pas versionnes : ils doivent provenir de la
charte graphique de l'entreprise.

Co-Authored-By: Claude Opus 5 <noreply@anthropic.com>
Claude-Session: https://claude.ai/code/session_013HeFSL5jx5KnB3FSreC4S1
</commit_message>
<xml_diff>
--- a/rapport/Soutenance_Bloc4_VRV_Intermarche_Rive-de-Gier.pptx
+++ b/rapport/Soutenance_Bloc4_VRV_Intermarche_Rive-de-Gier.pptx
@@ -5262,7 +5262,7 @@
         </p:nvSpPr>
         <p:spPr>
           <a:xfrm>
-            <a:off x="0" y="4031999"/>
+            <a:off x="0" y="4104000"/>
             <a:ext cx="12193200" cy="43200"/>
           </a:xfrm>
           <a:prstGeom prst="rect">
@@ -5388,8 +5388,8 @@
         </p:nvSpPr>
         <p:spPr>
           <a:xfrm>
-            <a:off x="900000" y="2160000"/>
-            <a:ext cx="10260000" cy="1440000"/>
+            <a:off x="900000" y="2052000"/>
+            <a:ext cx="10512000" cy="1512000"/>
           </a:xfrm>
           <a:prstGeom prst="rect">
             <a:avLst/>
@@ -5404,14 +5404,14 @@
           <a:p>
             <a:pPr algn="l">
               <a:lnSpc>
-                <a:spcPct val="110000"/>
-              </a:lnSpc>
-              <a:spcAft>
-                <a:spcPts val="400"/>
-              </a:spcAft>
-            </a:pPr>
-            <a:r>
-              <a:rPr sz="3400" b="1">
+                <a:spcPct val="115000"/>
+              </a:lnSpc>
+              <a:spcAft>
+                <a:spcPts val="400"/>
+              </a:spcAft>
+            </a:pPr>
+            <a:r>
+              <a:rPr sz="3000" b="1">
                 <a:solidFill>
                   <a:srgbClr val="FFFFFF"/>
                 </a:solidFill>
@@ -5423,14 +5423,14 @@
           <a:p>
             <a:pPr algn="l">
               <a:lnSpc>
-                <a:spcPct val="110000"/>
-              </a:lnSpc>
-              <a:spcAft>
-                <a:spcPts val="400"/>
-              </a:spcAft>
-            </a:pPr>
-            <a:r>
-              <a:rPr sz="3400" b="1">
+                <a:spcPct val="115000"/>
+              </a:lnSpc>
+              <a:spcAft>
+                <a:spcPts val="400"/>
+              </a:spcAft>
+            </a:pPr>
+            <a:r>
+              <a:rPr sz="3000" b="1">
                 <a:solidFill>
                   <a:srgbClr val="FFFFFF"/>
                 </a:solidFill>
@@ -5449,8 +5449,8 @@
         </p:nvSpPr>
         <p:spPr>
           <a:xfrm>
-            <a:off x="900000" y="3456000"/>
-            <a:ext cx="10260000" cy="432000"/>
+            <a:off x="900000" y="3491999"/>
+            <a:ext cx="10512000" cy="432000"/>
           </a:xfrm>
           <a:prstGeom prst="rect">
             <a:avLst/>
@@ -5472,7 +5472,7 @@
               </a:spcAft>
             </a:pPr>
             <a:r>
-              <a:rPr sz="1900" b="0">
+              <a:rPr sz="1800" b="0">
                 <a:solidFill>
                   <a:srgbClr val="C9DCEF"/>
                 </a:solidFill>
@@ -5754,7 +5754,7 @@
         <p:spPr>
           <a:xfrm>
             <a:off x="432000" y="306000"/>
-            <a:ext cx="10800000" cy="432000"/>
+            <a:ext cx="9360000" cy="432000"/>
           </a:xfrm>
           <a:prstGeom prst="rect">
             <a:avLst/>
@@ -7219,7 +7219,7 @@
         <p:spPr>
           <a:xfrm>
             <a:off x="432000" y="306000"/>
-            <a:ext cx="10800000" cy="432000"/>
+            <a:ext cx="9360000" cy="432000"/>
           </a:xfrm>
           <a:prstGeom prst="rect">
             <a:avLst/>
@@ -8214,7 +8214,7 @@
         <p:spPr>
           <a:xfrm>
             <a:off x="432000" y="306000"/>
-            <a:ext cx="10800000" cy="432000"/>
+            <a:ext cx="9360000" cy="432000"/>
           </a:xfrm>
           <a:prstGeom prst="rect">
             <a:avLst/>
@@ -9557,7 +9557,7 @@
         <p:spPr>
           <a:xfrm>
             <a:off x="432000" y="306000"/>
-            <a:ext cx="10800000" cy="432000"/>
+            <a:ext cx="9360000" cy="432000"/>
           </a:xfrm>
           <a:prstGeom prst="rect">
             <a:avLst/>
@@ -10608,7 +10608,7 @@
         <p:spPr>
           <a:xfrm>
             <a:off x="432000" y="306000"/>
-            <a:ext cx="10800000" cy="432000"/>
+            <a:ext cx="9360000" cy="432000"/>
           </a:xfrm>
           <a:prstGeom prst="rect">
             <a:avLst/>
@@ -12340,7 +12340,7 @@
         <p:spPr>
           <a:xfrm>
             <a:off x="432000" y="306000"/>
-            <a:ext cx="10800000" cy="432000"/>
+            <a:ext cx="9360000" cy="432000"/>
           </a:xfrm>
           <a:prstGeom prst="rect">
             <a:avLst/>
@@ -14008,7 +14008,7 @@
         <p:spPr>
           <a:xfrm>
             <a:off x="432000" y="306000"/>
-            <a:ext cx="10800000" cy="432000"/>
+            <a:ext cx="9360000" cy="432000"/>
           </a:xfrm>
           <a:prstGeom prst="rect">
             <a:avLst/>
@@ -15395,7 +15395,7 @@
         <p:spPr>
           <a:xfrm>
             <a:off x="432000" y="306000"/>
-            <a:ext cx="10800000" cy="432000"/>
+            <a:ext cx="9360000" cy="432000"/>
           </a:xfrm>
           <a:prstGeom prst="rect">
             <a:avLst/>
@@ -17093,7 +17093,7 @@
         <p:spPr>
           <a:xfrm>
             <a:off x="432000" y="306000"/>
-            <a:ext cx="10800000" cy="432000"/>
+            <a:ext cx="9360000" cy="432000"/>
           </a:xfrm>
           <a:prstGeom prst="rect">
             <a:avLst/>
@@ -18408,7 +18408,7 @@
         <p:spPr>
           <a:xfrm>
             <a:off x="432000" y="306000"/>
-            <a:ext cx="10800000" cy="432000"/>
+            <a:ext cx="9360000" cy="432000"/>
           </a:xfrm>
           <a:prstGeom prst="rect">
             <a:avLst/>
@@ -19702,7 +19702,7 @@
         <p:spPr>
           <a:xfrm>
             <a:off x="432000" y="306000"/>
-            <a:ext cx="10800000" cy="432000"/>
+            <a:ext cx="9360000" cy="432000"/>
           </a:xfrm>
           <a:prstGeom prst="rect">
             <a:avLst/>
@@ -20292,7 +20292,7 @@
         <p:spPr>
           <a:xfrm>
             <a:off x="432000" y="306000"/>
-            <a:ext cx="10800000" cy="432000"/>
+            <a:ext cx="9360000" cy="432000"/>
           </a:xfrm>
           <a:prstGeom prst="rect">
             <a:avLst/>
@@ -22042,7 +22042,7 @@
         <p:spPr>
           <a:xfrm>
             <a:off x="900000" y="5508000"/>
-            <a:ext cx="10260000" cy="432000"/>
+            <a:ext cx="7200000" cy="432000"/>
           </a:xfrm>
           <a:prstGeom prst="rect">
             <a:avLst/>
@@ -22186,7 +22186,7 @@
         <p:spPr>
           <a:xfrm>
             <a:off x="432000" y="306000"/>
-            <a:ext cx="10800000" cy="432000"/>
+            <a:ext cx="9360000" cy="432000"/>
           </a:xfrm>
           <a:prstGeom prst="rect">
             <a:avLst/>
@@ -23226,7 +23226,7 @@
         <p:spPr>
           <a:xfrm>
             <a:off x="432000" y="306000"/>
-            <a:ext cx="10800000" cy="432000"/>
+            <a:ext cx="9360000" cy="432000"/>
           </a:xfrm>
           <a:prstGeom prst="rect">
             <a:avLst/>
@@ -24654,7 +24654,7 @@
         <p:spPr>
           <a:xfrm>
             <a:off x="432000" y="306000"/>
-            <a:ext cx="10800000" cy="432000"/>
+            <a:ext cx="9360000" cy="432000"/>
           </a:xfrm>
           <a:prstGeom prst="rect">
             <a:avLst/>
@@ -25935,7 +25935,7 @@
         <p:spPr>
           <a:xfrm>
             <a:off x="432000" y="306000"/>
-            <a:ext cx="10800000" cy="432000"/>
+            <a:ext cx="9360000" cy="432000"/>
           </a:xfrm>
           <a:prstGeom prst="rect">
             <a:avLst/>
@@ -26815,7 +26815,7 @@
         <p:spPr>
           <a:xfrm>
             <a:off x="432000" y="306000"/>
-            <a:ext cx="10800000" cy="432000"/>
+            <a:ext cx="9360000" cy="432000"/>
           </a:xfrm>
           <a:prstGeom prst="rect">
             <a:avLst/>
@@ -28604,7 +28604,7 @@
         <p:spPr>
           <a:xfrm>
             <a:off x="432000" y="306000"/>
-            <a:ext cx="10800000" cy="432000"/>
+            <a:ext cx="9360000" cy="432000"/>
           </a:xfrm>
           <a:prstGeom prst="rect">
             <a:avLst/>
@@ -30789,7 +30789,7 @@
         <p:spPr>
           <a:xfrm>
             <a:off x="432000" y="306000"/>
-            <a:ext cx="10800000" cy="432000"/>
+            <a:ext cx="9360000" cy="432000"/>
           </a:xfrm>
           <a:prstGeom prst="rect">
             <a:avLst/>

</xml_diff>

<commit_message>
Relecture : numerotation, typographie francaise et corrections de fond
- Corrige trois sauts de numerotation nes des fusions de sections
  (2.7 -> 2.6, 3.2.5/6/7 -> 3.2.4/5/6, 3.10.3 -> 3.10.2) et tous les
  renvois croises correspondants, y compris l'annexe de correspondance
  avec la grille.
- Applique la typographie francaise a la generation des trois documents :
  espaces insecables avant la ponctuation double, dans les milliers,
  avant les unites et a l'interieur des guillemets.
- Corrige une comparaison inexacte sur le poids des liaisons frigorifiques
  par rapport aux groupes exterieurs.

Co-Authored-By: Claude Opus 5 <noreply@anthropic.com>
Claude-Session: https://claude.ai/code/session_013HeFSL5jx5KnB3FSreC4S1
</commit_message>
<xml_diff>
--- a/rapport/Soutenance_Bloc4_VRV_Intermarche_Rive-de-Gier.pptx
+++ b/rapport/Soutenance_Bloc4_VRV_Intermarche_Rive-de-Gier.pptx
@@ -5866,7 +5866,7 @@
                 </a:solidFill>
                 <a:latin typeface="Calibri"/>
               </a:rPr>
-              <a:t>1 min 30</a:t>
+              <a:t>1 min 30</a:t>
             </a:r>
           </a:p>
         </p:txBody>
@@ -6403,7 +6403,7 @@
                 </a:solidFill>
                 <a:latin typeface="Calibri"/>
               </a:rPr>
-              <a:t>LA RÉPARTITION DES CONSOMMATIONS — 1 219 000 kWh/an, soit 330,6 kWh/m²/an</a:t>
+              <a:t>LA RÉPARTITION DES CONSOMMATIONS — 1 219 000 kWh/an, soit 330,6 kWh/m²/an</a:t>
             </a:r>
           </a:p>
         </p:txBody>
@@ -7331,7 +7331,7 @@
                 </a:solidFill>
                 <a:latin typeface="Calibri"/>
               </a:rPr>
-              <a:t>2 min</a:t>
+              <a:t>2 min</a:t>
             </a:r>
           </a:p>
         </p:txBody>
@@ -7527,7 +7527,7 @@
                           </a:solidFill>
                           <a:latin typeface="Calibri"/>
                         </a:rPr>
-                        <a:t>Surface &gt; 1 000 m²
+                        <a:t>Surface &gt; 1 000 m²
 </a:t>
                       </a:r>
                       <a:r>
@@ -7537,7 +7537,7 @@
                           </a:solidFill>
                           <a:latin typeface="Calibri"/>
                         </a:rPr>
-                        <a:t>3 690 m²</a:t>
+                        <a:t>3 690 m²</a:t>
                       </a:r>
                     </a:p>
                   </a:txBody>
@@ -7590,7 +7590,7 @@
                           </a:solidFill>
                           <a:latin typeface="Calibri"/>
                         </a:rPr>
-                        <a:t>369,2 → 221,5 kWh/m²</a:t>
+                        <a:t>369,2 → 221,5 kWh/m²</a:t>
                       </a:r>
                     </a:p>
                   </a:txBody>
@@ -7636,7 +7636,7 @@
                           </a:solidFill>
                           <a:latin typeface="Calibri"/>
                         </a:rPr>
-                        <a:t>Puissance &gt; 70 kW
+                        <a:t>Puissance &gt; 70 kW
 </a:t>
                       </a:r>
                       <a:r>
@@ -7646,7 +7646,7 @@
                           </a:solidFill>
                           <a:latin typeface="Calibri"/>
                         </a:rPr>
-                        <a:t>chaudière de 452 kW</a:t>
+                        <a:t>chaudière de 452 kW</a:t>
                       </a:r>
                     </a:p>
                   </a:txBody>
@@ -7746,7 +7746,7 @@
                           </a:solidFill>
                           <a:latin typeface="Calibri"/>
                         </a:rPr>
-                        <a:t>Parking &gt; 1 500 m²
+                        <a:t>Parking &gt; 1 500 m²
 </a:t>
                       </a:r>
                       <a:r>
@@ -7756,7 +7756,7 @@
                           </a:solidFill>
                           <a:latin typeface="Calibri"/>
                         </a:rPr>
-                        <a:t>3 179 m²</a:t>
+                        <a:t>3 179 m²</a:t>
                       </a:r>
                     </a:p>
                   </a:txBody>
@@ -7800,7 +7800,7 @@
                           </a:solidFill>
                           <a:latin typeface="Calibri"/>
                         </a:rPr>
-                        <a:t>≈ 1 480 m² d'ombrières PV</a:t>
+                        <a:t>≈ 1 480 m² d'ombrières PV</a:t>
                       </a:r>
                     </a:p>
                   </a:txBody>
@@ -7996,7 +7996,7 @@
                 </a:solidFill>
                 <a:latin typeface="Calibri"/>
               </a:rPr>
-              <a:t>En cas de manquement au décret tertiaire :</a:t>
+              <a:t>En cas de manquement au décret tertiaire :</a:t>
             </a:r>
             <a:r>
               <a:rPr sz="1350" b="0">
@@ -8033,7 +8033,7 @@
                 </a:solidFill>
                 <a:latin typeface="Calibri"/>
               </a:rPr>
-              <a:t>sur un site public de l'État — le « name and shame » — et amende administrative jusqu'à </a:t>
+              <a:t>sur un site public de l'État — le « name and shame » — et amende administrative jusqu'à </a:t>
             </a:r>
             <a:r>
               <a:rPr sz="1350" b="1">
@@ -8042,7 +8042,7 @@
                 </a:solidFill>
                 <a:latin typeface="Calibri"/>
               </a:rPr>
-              <a:t>7 500 €</a:t>
+              <a:t>7 500 €</a:t>
             </a:r>
             <a:r>
               <a:rPr sz="1350" b="0">
@@ -8070,7 +8070,7 @@
                 </a:solidFill>
                 <a:latin typeface="Calibri"/>
               </a:rPr>
-              <a:t>L'argument qui porte n'est pas l'amende, c'est l'image et le report de la facture :</a:t>
+              <a:t>L'argument qui porte n'est pas l'amende, c'est l'image et le report de la facture :</a:t>
             </a:r>
             <a:r>
               <a:rPr sz="1350" b="0">
@@ -8326,7 +8326,7 @@
                 </a:solidFill>
                 <a:latin typeface="Calibri"/>
               </a:rPr>
-              <a:t>1 min 30</a:t>
+              <a:t>1 min 30</a:t>
             </a:r>
           </a:p>
         </p:txBody>
@@ -8515,7 +8515,7 @@
                 </a:solidFill>
                 <a:latin typeface="Calibri"/>
               </a:rPr>
-              <a:t>(RXYQ20U 20 CV + RXYQ16U 16 CV)</a:t>
+              <a:t>(RXYQ20U 20 CV + RXYQ16U 16 CV)</a:t>
             </a:r>
           </a:p>
           <a:p>
@@ -8544,7 +8544,7 @@
                 </a:solidFill>
                 <a:latin typeface="Calibri"/>
               </a:rPr>
-              <a:t>70,4 kW</a:t>
+              <a:t>70,4 kW</a:t>
             </a:r>
             <a:r>
               <a:rPr sz="1250" b="0">
@@ -8562,7 +8562,7 @@
                 </a:solidFill>
                 <a:latin typeface="Calibri"/>
               </a:rPr>
-              <a:t>89,5 kW</a:t>
+              <a:t>89,5 kW</a:t>
             </a:r>
             <a:r>
               <a:rPr sz="1250" b="0">
@@ -8654,7 +8654,7 @@
                 </a:solidFill>
                 <a:latin typeface="Calibri"/>
               </a:rPr>
-              <a:t>R-410A — 38 kg</a:t>
+              <a:t>R-410A — 38 kg</a:t>
             </a:r>
           </a:p>
         </p:txBody>
@@ -8793,7 +8793,7 @@
                 </a:solidFill>
                 <a:latin typeface="Calibri"/>
               </a:rPr>
-              <a:t> — 28 kW, 4 440 m³/h</a:t>
+              <a:t> — 28 kW, 4 440 m³/h</a:t>
             </a:r>
           </a:p>
           <a:p>
@@ -8821,7 +8821,7 @@
                 </a:solidFill>
                 <a:latin typeface="Calibri"/>
               </a:rPr>
-              <a:t>59 ml de gaine perforée Ø 550</a:t>
+              <a:t>59 ml de gaine perforée Ø 550</a:t>
             </a:r>
             <a:r>
               <a:rPr sz="1250" b="0">
@@ -8887,7 +8887,7 @@
                 </a:solidFill>
                 <a:latin typeface="Calibri"/>
               </a:rPr>
-              <a:t> Roundflow — 16 kW</a:t>
+              <a:t> Roundflow — 16 kW</a:t>
             </a:r>
           </a:p>
           <a:p>
@@ -8992,7 +8992,7 @@
                 </a:solidFill>
                 <a:latin typeface="Calibri"/>
               </a:rPr>
-              <a:t>POURQUOI UN DRV PLUTÔT QU'AUTRE CHOSE ?</a:t>
+              <a:t>POURQUOI UN DRV PLUTÔT QU'AUTRE CHOSE ?</a:t>
             </a:r>
           </a:p>
         </p:txBody>
@@ -9095,7 +9095,7 @@
                 </a:solidFill>
                 <a:latin typeface="Calibri"/>
               </a:rPr>
-              <a:t>47 800 € pour 2 250 €/an</a:t>
+              <a:t>47 800 € pour 2 250 €/an</a:t>
             </a:r>
           </a:p>
           <a:p>
@@ -9585,7 +9585,7 @@
                 </a:solidFill>
                 <a:latin typeface="Calibri"/>
               </a:rPr>
-              <a:t>452 kW remplacés par 70,4 kW</a:t>
+              <a:t>452 kW remplacés par 70,4 kW</a:t>
             </a:r>
           </a:p>
         </p:txBody>
@@ -9669,7 +9669,7 @@
                 </a:solidFill>
                 <a:latin typeface="Calibri"/>
               </a:rPr>
-              <a:t>1 min</a:t>
+              <a:t>1 min</a:t>
             </a:r>
           </a:p>
         </p:txBody>
@@ -9797,7 +9797,7 @@
                 </a:solidFill>
                 <a:latin typeface="Calibri"/>
               </a:rPr>
-              <a:t>452 kW</a:t>
+              <a:t>452 kW</a:t>
             </a:r>
           </a:p>
         </p:txBody>
@@ -9967,7 +9967,7 @@
                 </a:solidFill>
                 <a:latin typeface="Calibri"/>
               </a:rPr>
-              <a:t>70,4 kW</a:t>
+              <a:t>70,4 kW</a:t>
             </a:r>
           </a:p>
         </p:txBody>
@@ -10051,7 +10051,7 @@
                 </a:solidFill>
                 <a:latin typeface="Calibri"/>
               </a:rPr>
-              <a:t>SOIT UNE PUISSANCE DIVISÉE PAR 6,4 — POURQUOI ?</a:t>
+              <a:t>SOIT UNE PUISSANCE DIVISÉE PAR 6,4 — POURQUOI ?</a:t>
             </a:r>
           </a:p>
         </p:txBody>
@@ -10255,7 +10255,7 @@
                 </a:solidFill>
                 <a:latin typeface="Calibri"/>
               </a:rPr>
-              <a:t> depuis : toiture, doublages, extension récente</a:t>
+              <a:t> depuis : toiture, doublages, extension récente</a:t>
             </a:r>
           </a:p>
         </p:txBody>
@@ -10348,7 +10348,7 @@
                 </a:solidFill>
                 <a:latin typeface="Calibri"/>
               </a:rPr>
-              <a:t> : éclairage, occupants, et surtout les rejets des groupes de froid alimentaire (37 % des consommations)</a:t>
+              <a:t> : éclairage, occupants, et surtout les rejets des groupes de froid alimentaire (37 % des consommations)</a:t>
             </a:r>
           </a:p>
         </p:txBody>
@@ -10720,7 +10720,7 @@
                 </a:solidFill>
                 <a:latin typeface="Calibri"/>
               </a:rPr>
-              <a:t>1 min 30</a:t>
+              <a:t>1 min 30</a:t>
             </a:r>
           </a:p>
         </p:txBody>
@@ -10848,7 +10848,7 @@
                 </a:solidFill>
                 <a:latin typeface="Calibri"/>
               </a:rPr>
-              <a:t>90 000 €</a:t>
+              <a:t>90 000 €</a:t>
             </a:r>
           </a:p>
         </p:txBody>
@@ -10976,7 +10976,7 @@
                 </a:solidFill>
                 <a:latin typeface="Calibri"/>
               </a:rPr>
-              <a:t>11 000 €</a:t>
+              <a:t>11 000 €</a:t>
             </a:r>
           </a:p>
         </p:txBody>
@@ -11123,7 +11123,7 @@
                 </a:solidFill>
                 <a:latin typeface="Calibri"/>
               </a:rPr>
-              <a:t>79 000 €</a:t>
+              <a:t>79 000 €</a:t>
             </a:r>
           </a:p>
         </p:txBody>
@@ -12086,7 +12086,7 @@
                 </a:solidFill>
                 <a:latin typeface="Calibri"/>
               </a:rPr>
-              <a:t> un usage : + 102 MWh de climatisation.</a:t>
+              <a:t> un usage : + 102 MWh de climatisation.</a:t>
             </a:r>
           </a:p>
           <a:p>
@@ -12115,7 +12115,7 @@
                 </a:solidFill>
                 <a:latin typeface="Calibri"/>
               </a:rPr>
-              <a:t>Ce qui justifie le projet : </a:t>
+              <a:t>Ce qui justifie le projet : </a:t>
             </a:r>
             <a:r>
               <a:rPr sz="1200" b="1">
@@ -12151,7 +12151,7 @@
                 </a:solidFill>
                 <a:latin typeface="Calibri"/>
               </a:rPr>
-              <a:t> sur 2 596 m², </a:t>
+              <a:t> sur 2 596 m², </a:t>
             </a:r>
             <a:r>
               <a:rPr sz="1200" b="1">
@@ -12452,7 +12452,7 @@
                 </a:solidFill>
                 <a:latin typeface="Calibri"/>
               </a:rPr>
-              <a:t>2 min</a:t>
+              <a:t>2 min</a:t>
             </a:r>
           </a:p>
         </p:txBody>
@@ -12727,7 +12727,7 @@
                 </a:solidFill>
                 <a:latin typeface="Calibri"/>
               </a:rPr>
-              <a:t>19 h 45 → 4 h 45</a:t>
+              <a:t>19 h 45 → 4 h 45</a:t>
             </a:r>
           </a:p>
         </p:txBody>
@@ -12769,7 +12769,7 @@
                 </a:solidFill>
                 <a:latin typeface="Calibri"/>
               </a:rPr>
-              <a:t>soit 8 h de fenêtre utile</a:t>
+              <a:t>soit 8 h de fenêtre utile</a:t>
             </a:r>
           </a:p>
         </p:txBody>
@@ -13225,7 +13225,7 @@
                 </a:solidFill>
                 <a:latin typeface="Calibri"/>
               </a:rPr>
-              <a:t>Période 21 h – 6 h · 8 h max/jour</a:t>
+              <a:t>Période 21 h – 6 h · 8 h max/jour</a:t>
             </a:r>
           </a:p>
           <a:p>
@@ -13244,7 +13244,7 @@
                 </a:solidFill>
                 <a:latin typeface="Calibri"/>
               </a:rPr>
-              <a:t>40 h en moyenne sur 12 semaines</a:t>
+              <a:t>40 h en moyenne sur 12 semaines</a:t>
             </a:r>
           </a:p>
           <a:p>
@@ -13291,7 +13291,7 @@
                 </a:solidFill>
                 <a:latin typeface="Calibri"/>
               </a:rPr>
-              <a:t> : apprentis exclus</a:t>
+              <a:t> : apprentis exclus</a:t>
             </a:r>
           </a:p>
         </p:txBody>
@@ -13556,7 +13556,7 @@
                 </a:solidFill>
                 <a:latin typeface="Calibri"/>
               </a:rPr>
-              <a:t>avant 4 h 45</a:t>
+              <a:t>avant 4 h 45</a:t>
             </a:r>
           </a:p>
           <a:p>
@@ -13756,7 +13756,7 @@
                 </a:solidFill>
                 <a:latin typeface="Calibri"/>
               </a:rPr>
-              <a:t> : nacelle, pas d'échelle (R. 4323-58)</a:t>
+              <a:t> : nacelle, pas d'échelle (R. 4323-58)</a:t>
             </a:r>
           </a:p>
           <a:p>
@@ -13892,7 +13892,7 @@
                 </a:solidFill>
                 <a:latin typeface="Calibri"/>
               </a:rPr>
-              <a:t> (&gt; 400 h et travaux dangereux) + inspection commune préalable avec le magasin.</a:t>
+              <a:t> (&gt; 400 h et travaux dangereux) + inspection commune préalable avec le magasin.</a:t>
             </a:r>
           </a:p>
         </p:txBody>
@@ -14120,7 +14120,7 @@
                 </a:solidFill>
                 <a:latin typeface="Calibri"/>
               </a:rPr>
-              <a:t>1 min 30</a:t>
+              <a:t>1 min 30</a:t>
             </a:r>
           </a:p>
         </p:txBody>
@@ -14248,7 +14248,7 @@
                 </a:solidFill>
                 <a:latin typeface="Calibri"/>
               </a:rPr>
-              <a:t>Le fait :</a:t>
+              <a:t>Le fait :</a:t>
             </a:r>
             <a:r>
               <a:rPr sz="1400" b="0">
@@ -14285,7 +14285,7 @@
                 </a:solidFill>
                 <a:latin typeface="Calibri"/>
               </a:rPr>
-              <a:t>par rapport au chiffrage. Ce n'est pas un incident : c'est un </a:t>
+              <a:t>par rapport au chiffrage. Ce n'est pas un incident : c'est un </a:t>
             </a:r>
             <a:r>
               <a:rPr sz="1400" b="1">
@@ -14429,7 +14429,7 @@
                 </a:solidFill>
                 <a:latin typeface="Calibri"/>
               </a:rPr>
-              <a:t>Fenêtre utile de 8 h, dont installation et repli quotidiens</a:t>
+              <a:t>Fenêtre utile de 8 h, dont installation et repli quotidiens</a:t>
             </a:r>
           </a:p>
         </p:txBody>
@@ -14606,7 +14606,7 @@
                 </a:solidFill>
                 <a:latin typeface="Calibri"/>
               </a:rPr>
-              <a:t>70 % en nacelle : réinstallation à chaque zone</a:t>
+              <a:t>70 % en nacelle : réinstallation à chaque zone</a:t>
             </a:r>
           </a:p>
         </p:txBody>
@@ -14690,7 +14690,7 @@
                 </a:solidFill>
                 <a:latin typeface="Calibri"/>
               </a:rPr>
-              <a:t>59 ml de gaine à aligner en hauteur</a:t>
+              <a:t>59 ml de gaine à aligner en hauteur</a:t>
             </a:r>
           </a:p>
         </p:txBody>
@@ -14948,7 +14948,7 @@
                 </a:solidFill>
                 <a:latin typeface="Calibri"/>
               </a:rPr>
-              <a:t> du magasin : l'écart a été absorbé par l'entreprise, </a:t>
+              <a:t> du magasin : l'écart a été absorbé par l'entreprise, </a:t>
             </a:r>
             <a:r>
               <a:rPr sz="1250" b="1">
@@ -15146,7 +15146,7 @@
                 </a:solidFill>
                 <a:latin typeface="Calibri"/>
               </a:rPr>
-              <a:t> une mauvaise estimation : la compensation est venue d'un levier ponctuel, pas de la méthode.</a:t>
+              <a:t> une mauvaise estimation : la compensation est venue d'un levier ponctuel, pas de la méthode.</a:t>
             </a:r>
           </a:p>
         </p:txBody>
@@ -15234,7 +15234,7 @@
                 </a:solidFill>
                 <a:latin typeface="Calibri"/>
               </a:rPr>
-              <a:t>La correction :</a:t>
+              <a:t>La correction :</a:t>
             </a:r>
             <a:r>
               <a:rPr sz="1150" b="0">
@@ -15507,7 +15507,7 @@
                 </a:solidFill>
                 <a:latin typeface="Calibri"/>
               </a:rPr>
-              <a:t>1 min 30</a:t>
+              <a:t>1 min 30</a:t>
             </a:r>
           </a:p>
         </p:txBody>
@@ -15703,7 +15703,7 @@
                           </a:solidFill>
                           <a:latin typeface="Calibri"/>
                         </a:rPr>
-                        <a:t>1 219 000 kWh/an</a:t>
+                        <a:t>1 219 000 kWh/an</a:t>
                       </a:r>
                       <a:r>
                         <a:rPr sz="1200" b="0">
@@ -15713,7 +15713,7 @@
                           <a:latin typeface="Calibri"/>
                         </a:rPr>
                         <a:t>
-330,6 kWh/m²</a:t>
+330,6 kWh/m²</a:t>
                       </a:r>
                     </a:p>
                   </a:txBody>
@@ -15735,8 +15735,8 @@
                           </a:solidFill>
                           <a:latin typeface="Calibri"/>
                         </a:rPr>
-                        <a:t>objectif bouquet :
-779 000 kWh — 211,2 kWh/m²</a:t>
+                        <a:t>objectif bouquet :
+779 000 kWh — 211,2 kWh/m²</a:t>
                       </a:r>
                     </a:p>
                   </a:txBody>
@@ -15804,7 +15804,7 @@
                           </a:solidFill>
                           <a:latin typeface="Calibri"/>
                         </a:rPr>
-                        <a:t>369,2 kWh/m²</a:t>
+                        <a:t>369,2 kWh/m²</a:t>
                       </a:r>
                     </a:p>
                   </a:txBody>
@@ -15826,7 +15826,7 @@
                           </a:solidFill>
                           <a:latin typeface="Calibri"/>
                         </a:rPr>
-                        <a:t>221,5 kWh/m²</a:t>
+                        <a:t>221,5 kWh/m²</a:t>
                       </a:r>
                       <a:r>
                         <a:rPr sz="1200" b="0">
@@ -15925,7 +15925,7 @@
                           </a:solidFill>
                           <a:latin typeface="Calibri"/>
                         </a:rPr>
-                        <a:t>16 679 kgCO₂e/an</a:t>
+                        <a:t>16 679 kgCO₂e/an</a:t>
                       </a:r>
                     </a:p>
                   </a:txBody>
@@ -15947,7 +15947,7 @@
                           </a:solidFill>
                           <a:latin typeface="Calibri"/>
                         </a:rPr>
-                        <a:t>76 650 km en voiture</a:t>
+                        <a:t>76 650 km en voiture</a:t>
                       </a:r>
                     </a:p>
                   </a:txBody>
@@ -16015,7 +16015,7 @@
                           </a:solidFill>
                           <a:latin typeface="Calibri"/>
                         </a:rPr>
-                        <a:t>64 830 kgCO₂e/an</a:t>
+                        <a:t>64 830 kgCO₂e/an</a:t>
                       </a:r>
                     </a:p>
                   </a:txBody>
@@ -16313,7 +16313,7 @@
                 </a:solidFill>
                 <a:latin typeface="Calibri"/>
               </a:rPr>
-              <a:t>Comment je vérifierai réellement le gain :</a:t>
+              <a:t>Comment je vérifierai réellement le gain :</a:t>
             </a:r>
             <a:r>
               <a:rPr sz="1300" b="0">
@@ -16851,7 +16851,7 @@
                 </a:solidFill>
                 <a:latin typeface="Calibri"/>
               </a:rPr>
-              <a:t>L'équipe : organisation et axes d'amélioration</a:t>
+              <a:t>L'équipe : organisation et axes d'amélioration</a:t>
             </a:r>
           </a:p>
         </p:txBody>
@@ -17205,7 +17205,7 @@
                 </a:solidFill>
                 <a:latin typeface="Calibri"/>
               </a:rPr>
-              <a:t>1 min 30</a:t>
+              <a:t>1 min 30</a:t>
             </a:r>
           </a:p>
         </p:txBody>
@@ -17537,7 +17537,7 @@
                 </a:solidFill>
                 <a:latin typeface="Calibri"/>
               </a:rPr>
-              <a:t> : une expertise inaccessible à une PME seule</a:t>
+              <a:t> : une expertise inaccessible à une PME seule</a:t>
             </a:r>
           </a:p>
         </p:txBody>
@@ -17630,7 +17630,7 @@
                 </a:solidFill>
                 <a:latin typeface="Calibri"/>
               </a:rPr>
-              <a:t> : liaisons GTB posées, GTC plus tard</a:t>
+              <a:t> : liaisons GTB posées, GTC plus tard</a:t>
             </a:r>
           </a:p>
         </p:txBody>
@@ -17723,7 +17723,7 @@
                 </a:solidFill>
                 <a:latin typeface="Calibri"/>
               </a:rPr>
-              <a:t> : 452 → 70,4 kW</a:t>
+              <a:t> : 452 → 70,4 kW</a:t>
             </a:r>
           </a:p>
         </p:txBody>
@@ -17995,7 +17995,7 @@
                 </a:solidFill>
                 <a:latin typeface="Calibri"/>
               </a:rPr>
-              <a:t> : 38 kg de R-410A = </a:t>
+              <a:t> : 38 kg de R-410A = </a:t>
             </a:r>
             <a:r>
               <a:rPr sz="1250" b="1">
@@ -18013,7 +18013,7 @@
                 </a:solidFill>
                 <a:latin typeface="Calibri"/>
               </a:rPr>
-              <a:t>, soit 4,8 années de gain. Au R-32 : 25,7 t, et contrôle annuel au lieu de semestriel</a:t>
+              <a:t>, soit 4,8 années de gain. Au R-32 : 25,7 t, et contrôle annuel au lieu de semestriel</a:t>
             </a:r>
           </a:p>
         </p:txBody>
@@ -18818,7 +18818,7 @@
                 </a:solidFill>
                 <a:latin typeface="Calibri"/>
               </a:rPr>
-              <a:t>3 min</a:t>
+              <a:t>3 min</a:t>
             </a:r>
           </a:p>
         </p:txBody>
@@ -19074,7 +19074,7 @@
                 </a:solidFill>
                 <a:latin typeface="Calibri"/>
               </a:rPr>
-              <a:t>2 min</a:t>
+              <a:t>2 min</a:t>
             </a:r>
           </a:p>
         </p:txBody>
@@ -19330,7 +19330,7 @@
                 </a:solidFill>
                 <a:latin typeface="Calibri"/>
               </a:rPr>
-              <a:t>11 min</a:t>
+              <a:t>11 min</a:t>
             </a:r>
           </a:p>
         </p:txBody>
@@ -19586,7 +19586,7 @@
                 </a:solidFill>
                 <a:latin typeface="Calibri"/>
               </a:rPr>
-              <a:t>4 min</a:t>
+              <a:t>4 min</a:t>
             </a:r>
           </a:p>
         </p:txBody>
@@ -19814,7 +19814,7 @@
                 </a:solidFill>
                 <a:latin typeface="Calibri"/>
               </a:rPr>
-              <a:t>1 min</a:t>
+              <a:t>1 min</a:t>
             </a:r>
           </a:p>
         </p:txBody>
@@ -20056,7 +20056,7 @@
                           </a:solidFill>
                           <a:latin typeface="Calibri"/>
                         </a:rPr>
-                        <a:t>Effectif de 2 sans marge · transmission nuit/jour décalée de 24 h · isolement de l'équipe de nuit · fatigue</a:t>
+                        <a:t>Effectif de 2 sans marge · transmission nuit/jour décalée de 24 h · isolement de l'équipe de nuit · fatigue</a:t>
                       </a:r>
                     </a:p>
                   </a:txBody>
@@ -20148,7 +20148,7 @@
                           </a:solidFill>
                           <a:latin typeface="Calibri"/>
                         </a:rPr>
-                        <a:t>Aménagement de poste avec le médecin du travail et le référent handicap : tâches de </a:t>
+                        <a:t>Aménagement de poste avec le médecin du travail et le référent handicap : tâches de </a:t>
                       </a:r>
                       <a:r>
                         <a:rPr sz="1250" b="1">
@@ -20635,7 +20635,7 @@
                 </a:solidFill>
                 <a:latin typeface="Calibri"/>
               </a:rPr>
-              <a:t>34 200 € — </a:t>
+              <a:t>34 200 € — </a:t>
             </a:r>
             <a:r>
               <a:rPr sz="1100" b="1">
@@ -20814,7 +20814,7 @@
                 </a:solidFill>
                 <a:latin typeface="Calibri"/>
               </a:rPr>
-              <a:t>39 000 € — </a:t>
+              <a:t>39 000 € — </a:t>
             </a:r>
             <a:r>
               <a:rPr sz="1100" b="1">
@@ -21031,7 +21031,7 @@
                 </a:solidFill>
                 <a:latin typeface="Calibri"/>
               </a:rPr>
-              <a:t>8 840 € — </a:t>
+              <a:t>8 840 € — </a:t>
             </a:r>
             <a:r>
               <a:rPr sz="1100" b="1">
@@ -21229,7 +21229,7 @@
                 </a:solidFill>
                 <a:latin typeface="Calibri"/>
               </a:rPr>
-              <a:t>368 000 € — </a:t>
+              <a:t>368 000 € — </a:t>
             </a:r>
             <a:r>
               <a:rPr sz="1100" b="1">
@@ -21474,7 +21474,7 @@
                 </a:solidFill>
                 <a:latin typeface="Calibri"/>
               </a:rPr>
-              <a:t>restant : 58 % des consos</a:t>
+              <a:t>restant : 58 % des consos</a:t>
             </a:r>
           </a:p>
         </p:txBody>
@@ -21562,7 +21562,7 @@
                 </a:solidFill>
                 <a:latin typeface="Calibri"/>
               </a:rPr>
-              <a:t>Le bouquet complet : 572 940 € HT · 58 590 € d'économies par an · 9,3 ans de retour · − 70 % d'émissions.</a:t>
+              <a:t>Le bouquet complet : 572 940 € HT · 58 590 € d'économies par an · 9,3 ans de retour · − 70 % d'émissions.</a:t>
             </a:r>
           </a:p>
           <a:p>
@@ -21599,7 +21599,7 @@
                 </a:solidFill>
                 <a:latin typeface="Calibri"/>
               </a:rPr>
-              <a:t> de cette trajectoire : sans PAC réversible, pas de sortie du gaz,</a:t>
+              <a:t> de cette trajectoire : sans PAC réversible, pas de sortie du gaz,</a:t>
             </a:r>
           </a:p>
           <a:p>
@@ -21832,7 +21832,7 @@
                 </a:solidFill>
                 <a:latin typeface="Calibri"/>
               </a:rPr>
-              <a:t>pompe à chaleur réversible de 70,4 kW</a:t>
+              <a:t>pompe à chaleur réversible de 70,4 kW</a:t>
             </a:r>
             <a:r>
               <a:rPr sz="1700" b="0">
@@ -21906,7 +21906,7 @@
                 </a:solidFill>
                 <a:latin typeface="Calibri"/>
               </a:rPr>
-              <a:t>90 000 € HT dont 11 000 € financés par les CEE</a:t>
+              <a:t>90 000 € HT dont 11 000 € financés par les CEE</a:t>
             </a:r>
             <a:r>
               <a:rPr sz="1700" b="0">
@@ -21990,7 +21990,7 @@
                 </a:solidFill>
                 <a:latin typeface="Calibri"/>
               </a:rPr>
-              <a:t> :</a:t>
+              <a:t> :</a:t>
             </a:r>
           </a:p>
           <a:p>
@@ -22214,7 +22214,7 @@
                 </a:solidFill>
                 <a:latin typeface="Calibri"/>
               </a:rPr>
-              <a:t>Détail du devis — 92 939,39 € HT ramenés à 90 000 €</a:t>
+              <a:t>Détail du devis — 92 939,39 € HT ramenés à 90 000 €</a:t>
             </a:r>
           </a:p>
         </p:txBody>
@@ -22451,7 +22451,7 @@
                           </a:solidFill>
                           <a:latin typeface="Calibri"/>
                         </a:rPr>
-                        <a:t>11 055,30 €</a:t>
+                        <a:t>11 055,30 €</a:t>
                       </a:r>
                     </a:p>
                   </a:txBody>
@@ -22565,7 +22565,7 @@
                           </a:solidFill>
                           <a:latin typeface="Calibri"/>
                         </a:rPr>
-                        <a:t>SIONAIR GMD perforée Ø 550 — 59 ml</a:t>
+                        <a:t>SIONAIR GMD perforée Ø 550 — 59 ml</a:t>
                       </a:r>
                     </a:p>
                   </a:txBody>
@@ -22587,7 +22587,7 @@
                           </a:solidFill>
                           <a:latin typeface="Calibri"/>
                         </a:rPr>
-                        <a:t>8 991,82 €</a:t>
+                        <a:t>8 991,82 €</a:t>
                       </a:r>
                     </a:p>
                   </a:txBody>
@@ -22723,7 +22723,7 @@
                           </a:solidFill>
                           <a:latin typeface="Calibri"/>
                         </a:rPr>
-                        <a:t>30 036,98 €</a:t>
+                        <a:t>30 036,98 €</a:t>
                       </a:r>
                     </a:p>
                   </a:txBody>
@@ -22791,7 +22791,7 @@
                           </a:solidFill>
                           <a:latin typeface="Calibri"/>
                         </a:rPr>
-                        <a:t>20 307,90 €</a:t>
+                        <a:t>20 307,90 €</a:t>
                       </a:r>
                     </a:p>
                   </a:txBody>
@@ -22859,7 +22859,7 @@
                           </a:solidFill>
                           <a:latin typeface="Calibri"/>
                         </a:rPr>
-                        <a:t>1 471,59 €</a:t>
+                        <a:t>1 471,59 €</a:t>
                       </a:r>
                     </a:p>
                   </a:txBody>
@@ -22936,7 +22936,7 @@
                           </a:solidFill>
                           <a:latin typeface="Calibri"/>
                         </a:rPr>
-                        <a:t>8 388,75 €</a:t>
+                        <a:t>8 388,75 €</a:t>
                       </a:r>
                     </a:p>
                   </a:txBody>
@@ -22982,7 +22982,7 @@
                           </a:solidFill>
                           <a:latin typeface="Calibri"/>
                         </a:rPr>
-                        <a:t>Travail en horaire décalé 9 715,85 €</a:t>
+                        <a:t>Travail en horaire décalé 9 715,85 €</a:t>
                       </a:r>
                       <a:r>
                         <a:rPr sz="1150" b="0">
@@ -23013,7 +23013,7 @@
                           </a:solidFill>
                           <a:latin typeface="Calibri"/>
                         </a:rPr>
-                        <a:t>11 360,42 €</a:t>
+                        <a:t>11 360,42 €</a:t>
                       </a:r>
                     </a:p>
                   </a:txBody>
@@ -23065,7 +23065,7 @@
                 </a:solidFill>
                 <a:latin typeface="Calibri"/>
               </a:rPr>
-              <a:t>Remise − 2 939,39 € → </a:t>
+              <a:t>Remise − 2 939,39 € → </a:t>
             </a:r>
             <a:r>
               <a:rPr sz="1350" b="1">
@@ -23074,7 +23074,7 @@
                 </a:solidFill>
                 <a:latin typeface="Calibri"/>
               </a:rPr>
-              <a:t>90 000 € HT</a:t>
+              <a:t>90 000 € HT</a:t>
             </a:r>
             <a:r>
               <a:rPr sz="1350" b="0">
@@ -23083,7 +23083,7 @@
                 </a:solidFill>
                 <a:latin typeface="Calibri"/>
               </a:rPr>
-              <a:t> · TVA 20 % → 108 000 € TTC · </a:t>
+              <a:t> · TVA 20 % → 108 000 € TTC · </a:t>
             </a:r>
             <a:r>
               <a:rPr sz="1350" b="1">
@@ -23092,7 +23092,7 @@
                 </a:solidFill>
                 <a:latin typeface="Calibri"/>
               </a:rPr>
-              <a:t>CEE − 11 000 €</a:t>
+              <a:t>CEE − 11 000 €</a:t>
             </a:r>
             <a:r>
               <a:rPr sz="1350" b="0">
@@ -23110,7 +23110,7 @@
                 </a:solidFill>
                 <a:latin typeface="Calibri"/>
               </a:rPr>
-              <a:t>97 000 € TTC</a:t>
+              <a:t>97 000 € TTC</a:t>
             </a:r>
           </a:p>
         </p:txBody>
@@ -23515,7 +23515,7 @@
                           </a:solidFill>
                           <a:latin typeface="Calibri"/>
                         </a:rPr>
-                        <a:t>34 200 €</a:t>
+                        <a:t>34 200 €</a:t>
                       </a:r>
                     </a:p>
                   </a:txBody>
@@ -23537,7 +23537,7 @@
                           </a:solidFill>
                           <a:latin typeface="Calibri"/>
                         </a:rPr>
-                        <a:t>6 400 €</a:t>
+                        <a:t>6 400 €</a:t>
                       </a:r>
                     </a:p>
                   </a:txBody>
@@ -23627,7 +23627,7 @@
                           </a:solidFill>
                           <a:latin typeface="Calibri"/>
                         </a:rPr>
-                        <a:t>39 000 €</a:t>
+                        <a:t>39 000 €</a:t>
                       </a:r>
                     </a:p>
                   </a:txBody>
@@ -23649,7 +23649,7 @@
                           </a:solidFill>
                           <a:latin typeface="Calibri"/>
                         </a:rPr>
-                        <a:t>5 400 €</a:t>
+                        <a:t>5 400 €</a:t>
                       </a:r>
                     </a:p>
                   </a:txBody>
@@ -23739,7 +23739,7 @@
                           </a:solidFill>
                           <a:latin typeface="Calibri"/>
                         </a:rPr>
-                        <a:t>8 840 €</a:t>
+                        <a:t>8 840 €</a:t>
                       </a:r>
                     </a:p>
                   </a:txBody>
@@ -23761,7 +23761,7 @@
                           </a:solidFill>
                           <a:latin typeface="Calibri"/>
                         </a:rPr>
-                        <a:t>1 410 €</a:t>
+                        <a:t>1 410 €</a:t>
                       </a:r>
                     </a:p>
                   </a:txBody>
@@ -23851,7 +23851,7 @@
                           </a:solidFill>
                           <a:latin typeface="Calibri"/>
                         </a:rPr>
-                        <a:t>1 680 €</a:t>
+                        <a:t>1 680 €</a:t>
                       </a:r>
                     </a:p>
                   </a:txBody>
@@ -23963,7 +23963,7 @@
                           </a:solidFill>
                           <a:latin typeface="Calibri"/>
                         </a:rPr>
-                        <a:t>368 000 €</a:t>
+                        <a:t>368 000 €</a:t>
                       </a:r>
                     </a:p>
                   </a:txBody>
@@ -23985,7 +23985,7 @@
                           </a:solidFill>
                           <a:latin typeface="Calibri"/>
                         </a:rPr>
-                        <a:t>43 830 €</a:t>
+                        <a:t>43 830 €</a:t>
                       </a:r>
                     </a:p>
                   </a:txBody>
@@ -24075,7 +24075,7 @@
                           </a:solidFill>
                           <a:latin typeface="Calibri"/>
                         </a:rPr>
-                        <a:t>69 800 €</a:t>
+                        <a:t>69 800 €</a:t>
                       </a:r>
                     </a:p>
                   </a:txBody>
@@ -24097,7 +24097,7 @@
                           </a:solidFill>
                           <a:latin typeface="Calibri"/>
                         </a:rPr>
-                        <a:t>6 300 €</a:t>
+                        <a:t>6 300 €</a:t>
                       </a:r>
                     </a:p>
                   </a:txBody>
@@ -24187,7 +24187,7 @@
                           </a:solidFill>
                           <a:latin typeface="Calibri"/>
                         </a:rPr>
-                        <a:t>47 800 €</a:t>
+                        <a:t>47 800 €</a:t>
                       </a:r>
                     </a:p>
                   </a:txBody>
@@ -24209,7 +24209,7 @@
                           </a:solidFill>
                           <a:latin typeface="Calibri"/>
                         </a:rPr>
-                        <a:t>2 250 €</a:t>
+                        <a:t>2 250 €</a:t>
                       </a:r>
                     </a:p>
                   </a:txBody>
@@ -24299,7 +24299,7 @@
                           </a:solidFill>
                           <a:latin typeface="Calibri"/>
                         </a:rPr>
-                        <a:t>44 100 €</a:t>
+                        <a:t>44 100 €</a:t>
                       </a:r>
                     </a:p>
                   </a:txBody>
@@ -24321,7 +24321,7 @@
                           </a:solidFill>
                           <a:latin typeface="Calibri"/>
                         </a:rPr>
-                        <a:t>1 600 €</a:t>
+                        <a:t>1 600 €</a:t>
                       </a:r>
                     </a:p>
                   </a:txBody>
@@ -24411,7 +24411,7 @@
                           </a:solidFill>
                           <a:latin typeface="Calibri"/>
                         </a:rPr>
-                        <a:t>122 800 €</a:t>
+                        <a:t>122 800 €</a:t>
                       </a:r>
                     </a:p>
                   </a:txBody>
@@ -24433,7 +24433,7 @@
                           </a:solidFill>
                           <a:latin typeface="Calibri"/>
                         </a:rPr>
-                        <a:t>5 260 €</a:t>
+                        <a:t>5 260 €</a:t>
                       </a:r>
                     </a:p>
                   </a:txBody>
@@ -24529,7 +24529,7 @@
                 </a:solidFill>
                 <a:latin typeface="Calibri"/>
               </a:rPr>
-              <a:t>Bouquet retenu : </a:t>
+              <a:t>Bouquet retenu : </a:t>
             </a:r>
             <a:r>
               <a:rPr sz="1350" b="1">
@@ -24538,7 +24538,7 @@
                 </a:solidFill>
                 <a:latin typeface="Calibri"/>
               </a:rPr>
-              <a:t>572 940 € HT · 58 590 €/an · 26 700 € de subventions · 9,3 ans · − 70 % d'émissions</a:t>
+              <a:t>572 940 € HT · 58 590 €/an · 26 700 € de subventions · 9,3 ans · − 70 % d'émissions</a:t>
             </a:r>
           </a:p>
         </p:txBody>
@@ -24682,7 +24682,7 @@
                 </a:solidFill>
                 <a:latin typeface="Calibri"/>
               </a:rPr>
-              <a:t>Le fluide frigorigène : R-410A contre R-32</a:t>
+              <a:t>Le fluide frigorigène : R-410A contre R-32</a:t>
             </a:r>
           </a:p>
         </p:txBody>
@@ -24897,7 +24897,7 @@
                           </a:solidFill>
                           <a:latin typeface="Calibri"/>
                         </a:rPr>
-                        <a:t>38 kg</a:t>
+                        <a:t>38 kg</a:t>
                       </a:r>
                     </a:p>
                   </a:txBody>
@@ -24919,7 +24919,7 @@
                           </a:solidFill>
                           <a:latin typeface="Calibri"/>
                         </a:rPr>
-                        <a:t>38 kg</a:t>
+                        <a:t>38 kg</a:t>
                       </a:r>
                     </a:p>
                   </a:txBody>
@@ -24965,7 +24965,7 @@
                           </a:solidFill>
                           <a:latin typeface="Calibri"/>
                         </a:rPr>
-                        <a:t>2 088</a:t>
+                        <a:t>2 088</a:t>
                       </a:r>
                     </a:p>
                   </a:txBody>
@@ -25033,7 +25033,7 @@
                           </a:solidFill>
                           <a:latin typeface="Calibri"/>
                         </a:rPr>
-                        <a:t>79,3 t CO₂e</a:t>
+                        <a:t>79,3 t CO₂e</a:t>
                       </a:r>
                     </a:p>
                   </a:txBody>
@@ -25055,7 +25055,7 @@
                           </a:solidFill>
                           <a:latin typeface="Calibri"/>
                         </a:rPr>
-                        <a:t>25,7 t CO₂e</a:t>
+                        <a:t>25,7 t CO₂e</a:t>
                       </a:r>
                     </a:p>
                   </a:txBody>
@@ -25079,7 +25079,7 @@
                           </a:solidFill>
                           <a:latin typeface="Calibri"/>
                         </a:rPr>
-                        <a:t>Équivalent en années de gain (16,7 t/an)</a:t>
+                        <a:t>Équivalent en années de gain (16,7 t/an)</a:t>
                       </a:r>
                     </a:p>
                   </a:txBody>
@@ -25147,7 +25147,7 @@
                           </a:solidFill>
                           <a:latin typeface="Calibri"/>
                         </a:rPr>
-                        <a:t>Seuil des 50 t CO₂e</a:t>
+                        <a:t>Seuil des 50 t CO₂e</a:t>
                       </a:r>
                     </a:p>
                   </a:txBody>
@@ -25320,7 +25320,7 @@
                 </a:solidFill>
                 <a:latin typeface="Calibri"/>
               </a:rPr>
-              <a:t> : sur le bilan carbone réel du projet,</a:t>
+              <a:t> : sur le bilan carbone réel du projet,</a:t>
             </a:r>
           </a:p>
           <a:p>
@@ -25693,7 +25693,7 @@
                 </a:solidFill>
                 <a:latin typeface="Calibri"/>
               </a:rPr>
-              <a:t>Santerne Surfaces Commerciales : qui, quoi, où</a:t>
+              <a:t>Santerne Surfaces Commerciales : qui, quoi, où</a:t>
             </a:r>
           </a:p>
         </p:txBody>
@@ -26047,7 +26047,7 @@
                 </a:solidFill>
                 <a:latin typeface="Calibri"/>
               </a:rPr>
-              <a:t>1 min</a:t>
+              <a:t>1 min</a:t>
             </a:r>
           </a:p>
         </p:txBody>
@@ -26217,7 +26217,7 @@
                 </a:solidFill>
                 <a:latin typeface="Calibri"/>
               </a:rPr>
-              <a:t>61,6 Md€ · 219 300 collaborateurs</a:t>
+              <a:t>61,6 Md€ · 219 300 collaborateurs</a:t>
             </a:r>
           </a:p>
         </p:txBody>
@@ -26345,7 +26345,7 @@
                 </a:solidFill>
                 <a:latin typeface="Calibri"/>
               </a:rPr>
-              <a:t>16,7 Md€ · 1 800 entreprises · 57 pays</a:t>
+              <a:t>16,7 Md€ · 1 800 entreprises · 57 pays</a:t>
             </a:r>
           </a:p>
         </p:txBody>
@@ -26473,7 +26473,7 @@
                 </a:solidFill>
                 <a:latin typeface="Calibri"/>
               </a:rPr>
-              <a:t>277 M€ · 1 690 collaborateurs · 38 entreprises</a:t>
+              <a:t>277 M€ · 1 690 collaborateurs · 38 entreprises</a:t>
             </a:r>
           </a:p>
         </p:txBody>
@@ -26643,7 +26643,7 @@
                 </a:solidFill>
                 <a:latin typeface="Calibri"/>
               </a:rPr>
-              <a:t>Le modèle VINCI Energies : des entreprises autonomes, mises en réseau.</a:t>
+              <a:t>Le modèle VINCI Energies : des entreprises autonomes, mises en réseau.</a:t>
             </a:r>
           </a:p>
           <a:p>
@@ -26662,7 +26662,7 @@
                 </a:solidFill>
                 <a:latin typeface="Calibri"/>
               </a:rPr>
-              <a:t>C'est ce « maillage » qui m'a permis de mobiliser un </a:t>
+              <a:t>C'est ce « maillage » qui m'a permis de mobiliser un </a:t>
             </a:r>
             <a:r>
               <a:rPr sz="1400" b="1">
@@ -26680,7 +26680,7 @@
                 </a:solidFill>
                 <a:latin typeface="Calibri"/>
               </a:rPr>
-              <a:t> pour auditer le magasin :</a:t>
+              <a:t> pour auditer le magasin :</a:t>
             </a:r>
           </a:p>
           <a:p>
@@ -26927,7 +26927,7 @@
                 </a:solidFill>
                 <a:latin typeface="Calibri"/>
               </a:rPr>
-              <a:t>1 min 30</a:t>
+              <a:t>1 min 30</a:t>
             </a:r>
           </a:p>
         </p:txBody>
@@ -27515,7 +27515,7 @@
                 </a:solidFill>
                 <a:latin typeface="Calibri"/>
               </a:rPr>
-              <a:t>Clients : grande distribution, retail, tertiaire, collectivités.</a:t>
+              <a:t>Clients : grande distribution, retail, tertiaire, collectivités.</a:t>
             </a:r>
           </a:p>
         </p:txBody>
@@ -27603,7 +27603,7 @@
                 </a:solidFill>
                 <a:latin typeface="Calibri"/>
               </a:rPr>
-              <a:t>MON POSTE : CHARGÉ DE MAINTENANCE</a:t>
+              <a:t>MON POSTE : CHARGÉ DE MAINTENANCE</a:t>
             </a:r>
           </a:p>
         </p:txBody>
@@ -28046,7 +28046,7 @@
                 </a:solidFill>
                 <a:latin typeface="Calibri"/>
               </a:rPr>
-              <a:t>90 000 €</a:t>
+              <a:t>90 000 €</a:t>
             </a:r>
             <a:r>
               <a:rPr sz="1200" b="0">
@@ -28716,7 +28716,7 @@
                 </a:solidFill>
                 <a:latin typeface="Calibri"/>
               </a:rPr>
-              <a:t>2 min</a:t>
+              <a:t>2 min</a:t>
             </a:r>
           </a:p>
         </p:txBody>
@@ -29225,7 +29225,7 @@
                 </a:solidFill>
                 <a:latin typeface="Calibri"/>
               </a:rPr>
-              <a:t> :</a:t>
+              <a:t> :</a:t>
             </a:r>
           </a:p>
           <a:p>
@@ -30295,7 +30295,7 @@
                 </a:solidFill>
                 <a:latin typeface="Calibri"/>
               </a:rPr>
-              <a:t>Les obligations réglementaires : l'argument décisif</a:t>
+              <a:t>Les obligations réglementaires : l'argument décisif</a:t>
             </a:r>
           </a:p>
         </p:txBody>
@@ -30547,7 +30547,7 @@
                 </a:solidFill>
                 <a:latin typeface="Calibri"/>
               </a:rPr>
-              <a:t>Le chantier de nuit en ERP : sécurité et planning</a:t>
+              <a:t>Le chantier de nuit en ERP : sécurité et planning</a:t>
             </a:r>
           </a:p>
         </p:txBody>
@@ -30901,7 +30901,7 @@
                 </a:solidFill>
                 <a:latin typeface="Calibri"/>
               </a:rPr>
-              <a:t>1 min</a:t>
+              <a:t>1 min</a:t>
             </a:r>
           </a:p>
         </p:txBody>
@@ -31029,7 +31029,7 @@
                 </a:solidFill>
                 <a:latin typeface="Calibri"/>
               </a:rPr>
-              <a:t>3 690 m²</a:t>
+              <a:t>3 690 m²</a:t>
             </a:r>
           </a:p>
         </p:txBody>
@@ -31090,7 +31090,7 @@
                 </a:solidFill>
                 <a:latin typeface="Calibri"/>
               </a:rPr>
-              <a:t>dont 2 596 m² de vente</a:t>
+              <a:t>dont 2 596 m² de vente</a:t>
             </a:r>
           </a:p>
         </p:txBody>
@@ -31176,7 +31176,7 @@
                 </a:solidFill>
                 <a:latin typeface="Calibri"/>
               </a:rPr>
-              <a:t>452 kW</a:t>
+              <a:t>452 kW</a:t>
             </a:r>
           </a:p>
         </p:txBody>
@@ -31323,7 +31323,7 @@
                 </a:solidFill>
                 <a:latin typeface="Calibri"/>
               </a:rPr>
-              <a:t>4 h 45 – 19 h 45</a:t>
+              <a:t>4 h 45 – 19 h 45</a:t>
             </a:r>
           </a:p>
         </p:txBody>
@@ -31470,7 +31470,7 @@
                 </a:solidFill>
                 <a:latin typeface="Calibri"/>
               </a:rPr>
-              <a:t>165 340 €</a:t>
+              <a:t>165 340 €</a:t>
             </a:r>
           </a:p>
         </p:txBody>
@@ -32000,7 +32000,7 @@
                 </a:solidFill>
                 <a:latin typeface="Calibri"/>
               </a:rPr>
-              <a:t>Pas de GTB : régulation de </a:t>
+              <a:t>Pas de GTB : régulation de </a:t>
             </a:r>
             <a:r>
               <a:rPr sz="1250" b="1">

</xml_diff>